<commit_message>
Update M4 draft handoff with adopted integration and development findings
</commit_message>
<xml_diff>
--- a/M4/report/M4_Method_Draft.pptx
+++ b/M4/report/M4_Method_Draft.pptx
@@ -2,14 +2,14 @@
 <file path=ppt/presentation.xml><?xml version="1.0" encoding="utf-8"?>
 <p:presentation xmlns:p="http://schemas.openxmlformats.org/presentationml/2006/main">
   <p:sldMasterIdLst>
-    <p:sldMasterId xmlns:r="http://schemas.openxmlformats.org/officeDocument/2006/relationships" id="2147483648" r:id="Rafd5ec6d23ec4808"/>
+    <p:sldMasterId xmlns:r="http://schemas.openxmlformats.org/officeDocument/2006/relationships" id="2147483648" r:id="Rbeed4b8fe2e74c37"/>
   </p:sldMasterIdLst>
   <p:notesMasterIdLst>
-    <p:notesMasterId xmlns:r="http://schemas.openxmlformats.org/officeDocument/2006/relationships" r:id="Rb9d03fb13f4045d0"/>
+    <p:notesMasterId xmlns:r="http://schemas.openxmlformats.org/officeDocument/2006/relationships" r:id="R15ba0b5d4d1f49dd"/>
   </p:notesMasterIdLst>
   <p:sldIdLst>
-    <p:sldId xmlns:r="http://schemas.openxmlformats.org/officeDocument/2006/relationships" id="256" r:id="R69351587272f4233"/>
-    <p:sldId xmlns:r="http://schemas.openxmlformats.org/officeDocument/2006/relationships" id="257" r:id="R69c599fd74cc4a8e"/>
+    <p:sldId xmlns:r="http://schemas.openxmlformats.org/officeDocument/2006/relationships" id="256" r:id="R7ad2f2302901464a"/>
+    <p:sldId xmlns:r="http://schemas.openxmlformats.org/officeDocument/2006/relationships" id="257" r:id="R8626659274c64ccb"/>
   </p:sldIdLst>
   <p:sldSz cx="12192000" cy="6858000"/>
   <p:notesSz cx="6858000" cy="9144000"/>
@@ -443,7 +443,22 @@
           <a:lstStyle xmlns:a="http://schemas.openxmlformats.org/drawingml/2006/main"/>
           <a:p xmlns:a="http://schemas.openxmlformats.org/drawingml/2006/main">
             <a:r>
-              <a:t>Approximately 45 seconds. M4 separates complete experiment evidence from the bounded records returned to planning. Stability labels refer to the observed phase diagram at evaluation time. The standalone core additionally supports target-composition retrieval, but M1 get_memory() supplies no target, so that mode is not active through the adapter. Current main does not enable M4. Sources: M4/EVIDENCE_SCHEMA.md; M4/src/m4_memory/m1_adapter.py; M1/PLUGIN_INTERFACE.md; course brief, section 2.</a:t>
+              <a:t>M4 keeps a complete evidence log and supplies a bounded set of observations to planning. Each structure attempt has its own identity and retains public energy and stability feedback. The adapter returns recent observations with contrasting outcomes, up to eight records and 4,000 JSON characters. M1 has adopted the module, and M3 records the memory IDs used in its reviews. We export the official trajectory in both conditions to include the final query. Separate audit logs capture generator and filter events without feeding them back into decisions. Oracle exceptions remain outside this capture boundary.</a:t>
+            </a:r>
+          </a:p>
+          <a:p xmlns:a="http://schemas.openxmlformats.org/drawingml/2006/main">
+            <a:r>
+              <a:t/>
+            </a:r>
+          </a:p>
+          <a:p xmlns:a="http://schemas.openxmlformats.org/drawingml/2006/main">
+            <a:r>
+              <a:t/>
+            </a:r>
+          </a:p>
+          <a:p xmlns:a="http://schemas.openxmlformats.org/drawingml/2006/main">
+            <a:r>
+              <a:t>Sources: Slide 1: M4/EVIDENCE_SCHEMA.md, M4/src/m4_memory/m1_adapter.py, M4/src/m4_memory/capture.py, M1/PLUGIN_INTERFACE.md and adopted profile commit 3f8d48f.</a:t>
             </a:r>
           </a:p>
         </p:txBody>
@@ -513,7 +528,27 @@
           <a:lstStyle xmlns:a="http://schemas.openxmlformats.org/drawingml/2006/main"/>
           <a:p xmlns:a="http://schemas.openxmlformats.org/drawingml/2006/main">
             <a:r>
-              <a:t>Approximately 45 seconds. This figure is the official observed phase diagram from the saved real-material workflow, not evidence of a memory benefit. Original run: M1 protocol v1, m1_baseline, dev Mg-Sn-Sr, seed 17, attempt_02. Runtime 157.193 seconds includes initialization and the first model download. 203 MP entries loaded, 194 retained, and 112 known stable/near-stable structures re-evaluated during initialization. Campaign count is 20, not total oracle workload. Source: preserved official trajectory and run_metadata.json; M4/REAL_TEST_STATUS.md. After M1/M3 activate actual memory consumption, compare against the frozen full-agent reference using M6 settings. Add official results and cases only after controlled runs.</a:t>
+              <a:t>We tested one development pair on Mg-Sn-Sr with seed 17 and a budget of 20 queries per arm. Both used the M3 planner and CPU ORB, with exploration and routing off. Memory ON scored seven on mSUN and 68.5 on AUDC. OFF scored eight and 76.0, so this pair showed no benefit. ON stayed in Sn-Sr, while OFF also explored ternary compositions. The figure shows the ON run's observed phase diagram. This is a development finding from one system and seed. The formal ablation will compare the frozen full agent against Memory OFF with all other settings matched.</a:t>
+            </a:r>
+          </a:p>
+          <a:p xmlns:a="http://schemas.openxmlformats.org/drawingml/2006/main">
+            <a:r>
+              <a:t/>
+            </a:r>
+          </a:p>
+          <a:p xmlns:a="http://schemas.openxmlformats.org/drawingml/2006/main">
+            <a:r>
+              <a:t/>
+            </a:r>
+          </a:p>
+          <a:p xmlns:a="http://schemas.openxmlformats.org/drawingml/2006/main">
+            <a:r>
+              <a:t>Sources: Slide 2: M4/evidence/dev-pilot-20261021/paired_results.csv, audit.json, m3_trace_on.json, m3_trace_off.json and raw_outputs.zip. The figure is on/trajectories/phase_diagram_episode_000.png inside the ZIP. The base team revision is e1a40d8. M6/PROTOCOL_ADOPTION.md defines the final dev-only ablation. Initialization adds oracle work beyond the 20 campaign queries. Neither the single pair nor its runtime difference establishes a general effect or isolated Memory overhead.</a:t>
+            </a:r>
+          </a:p>
+          <a:p xmlns:a="http://schemas.openxmlformats.org/drawingml/2006/main">
+            <a:r>
+              <a:t/>
             </a:r>
           </a:p>
         </p:txBody>
@@ -2956,12 +2991,12 @@
   </p:cSld>
   <p:clrMap bg1="lt1" tx1="dk1" bg2="lt2" tx2="dk2" accent1="accent1" accent2="accent2" accent3="accent3" accent4="accent4" accent5="accent5" accent6="accent6" hlink="hlink" folHlink="folHlink"/>
   <p:sldLayoutIdLst>
-    <p:sldLayoutId xmlns:r="http://schemas.openxmlformats.org/officeDocument/2006/relationships" id="2147483649" r:id="Raf5e567a2e7b49bd"/>
-    <p:sldLayoutId xmlns:r="http://schemas.openxmlformats.org/officeDocument/2006/relationships" id="2147483650" r:id="R67f0fcd80a2144fb"/>
-    <p:sldLayoutId xmlns:r="http://schemas.openxmlformats.org/officeDocument/2006/relationships" id="2147483651" r:id="Rd105708640df4e06"/>
-    <p:sldLayoutId xmlns:r="http://schemas.openxmlformats.org/officeDocument/2006/relationships" id="2147483652" r:id="Ra4ef94775dc6472b"/>
-    <p:sldLayoutId xmlns:r="http://schemas.openxmlformats.org/officeDocument/2006/relationships" id="2147483653" r:id="Rdf539fb12bac4d25"/>
-    <p:sldLayoutId xmlns:r="http://schemas.openxmlformats.org/officeDocument/2006/relationships" id="2147483654" r:id="R6c746731a9044811"/>
+    <p:sldLayoutId xmlns:r="http://schemas.openxmlformats.org/officeDocument/2006/relationships" id="2147483649" r:id="R73febabea3cf4112"/>
+    <p:sldLayoutId xmlns:r="http://schemas.openxmlformats.org/officeDocument/2006/relationships" id="2147483650" r:id="Rec8ea4d589e34705"/>
+    <p:sldLayoutId xmlns:r="http://schemas.openxmlformats.org/officeDocument/2006/relationships" id="2147483651" r:id="R5c4bee214f8949a9"/>
+    <p:sldLayoutId xmlns:r="http://schemas.openxmlformats.org/officeDocument/2006/relationships" id="2147483652" r:id="R389a5f88a0784b39"/>
+    <p:sldLayoutId xmlns:r="http://schemas.openxmlformats.org/officeDocument/2006/relationships" id="2147483653" r:id="Re35e87b1f42a4274"/>
+    <p:sldLayoutId xmlns:r="http://schemas.openxmlformats.org/officeDocument/2006/relationships" id="2147483654" r:id="R5764e516a19f4070"/>
   </p:sldLayoutIdLst>
   <p:txStyles>
     <p:titleStyle>
@@ -3548,6 +3583,7 @@
               </a:defRPr>
             </a:defPPr>
             <a:lvl1pPr>
+              <a:buNone/>
               <a:defRPr sz="3600" b="1">
                 <a:solidFill>
                   <a:srgbClr val="152A43"/>
@@ -3558,6 +3594,7 @@
               </a:defRPr>
             </a:lvl1pPr>
             <a:lvl2pPr>
+              <a:buNone/>
               <a:defRPr sz="3600" b="1">
                 <a:solidFill>
                   <a:srgbClr val="152A43"/>
@@ -3568,6 +3605,7 @@
               </a:defRPr>
             </a:lvl2pPr>
             <a:lvl3pPr>
+              <a:buNone/>
               <a:defRPr sz="3600" b="1">
                 <a:solidFill>
                   <a:srgbClr val="152A43"/>
@@ -3578,6 +3616,7 @@
               </a:defRPr>
             </a:lvl3pPr>
             <a:lvl4pPr>
+              <a:buNone/>
               <a:defRPr sz="3600" b="1">
                 <a:solidFill>
                   <a:srgbClr val="152A43"/>
@@ -3588,6 +3627,7 @@
               </a:defRPr>
             </a:lvl4pPr>
             <a:lvl5pPr>
+              <a:buNone/>
               <a:defRPr sz="3600" b="1">
                 <a:solidFill>
                   <a:srgbClr val="152A43"/>
@@ -3598,6 +3638,7 @@
               </a:defRPr>
             </a:lvl5pPr>
             <a:lvl6pPr>
+              <a:buNone/>
               <a:defRPr sz="3600" b="1">
                 <a:solidFill>
                   <a:srgbClr val="152A43"/>
@@ -3608,6 +3649,7 @@
               </a:defRPr>
             </a:lvl6pPr>
             <a:lvl7pPr>
+              <a:buNone/>
               <a:defRPr sz="3600" b="1">
                 <a:solidFill>
                   <a:srgbClr val="152A43"/>
@@ -3618,6 +3660,7 @@
               </a:defRPr>
             </a:lvl7pPr>
             <a:lvl8pPr>
+              <a:buNone/>
               <a:defRPr sz="3600" b="1">
                 <a:solidFill>
                   <a:srgbClr val="152A43"/>
@@ -3628,6 +3671,7 @@
               </a:defRPr>
             </a:lvl8pPr>
             <a:lvl9pPr>
+              <a:buNone/>
               <a:defRPr sz="3600" b="1">
                 <a:solidFill>
                   <a:srgbClr val="152A43"/>
@@ -3640,6 +3684,7 @@
           </a:lstStyle>
           <a:p xmlns:a="http://schemas.openxmlformats.org/drawingml/2006/main">
             <a:pPr>
+              <a:buNone/>
               <a:defRPr sz="3600" b="1">
                 <a:solidFill>
                   <a:srgbClr val="152A43"/>
@@ -3704,6 +3749,7 @@
               </a:defRPr>
             </a:defPPr>
             <a:lvl1pPr>
+              <a:buNone/>
               <a:defRPr sz="2250" b="1">
                 <a:solidFill>
                   <a:srgbClr val="152A43"/>
@@ -3714,6 +3760,7 @@
               </a:defRPr>
             </a:lvl1pPr>
             <a:lvl2pPr>
+              <a:buNone/>
               <a:defRPr sz="2250" b="1">
                 <a:solidFill>
                   <a:srgbClr val="152A43"/>
@@ -3724,6 +3771,7 @@
               </a:defRPr>
             </a:lvl2pPr>
             <a:lvl3pPr>
+              <a:buNone/>
               <a:defRPr sz="2250" b="1">
                 <a:solidFill>
                   <a:srgbClr val="152A43"/>
@@ -3734,6 +3782,7 @@
               </a:defRPr>
             </a:lvl3pPr>
             <a:lvl4pPr>
+              <a:buNone/>
               <a:defRPr sz="2250" b="1">
                 <a:solidFill>
                   <a:srgbClr val="152A43"/>
@@ -3744,6 +3793,7 @@
               </a:defRPr>
             </a:lvl4pPr>
             <a:lvl5pPr>
+              <a:buNone/>
               <a:defRPr sz="2250" b="1">
                 <a:solidFill>
                   <a:srgbClr val="152A43"/>
@@ -3754,6 +3804,7 @@
               </a:defRPr>
             </a:lvl5pPr>
             <a:lvl6pPr>
+              <a:buNone/>
               <a:defRPr sz="2250" b="1">
                 <a:solidFill>
                   <a:srgbClr val="152A43"/>
@@ -3764,6 +3815,7 @@
               </a:defRPr>
             </a:lvl6pPr>
             <a:lvl7pPr>
+              <a:buNone/>
               <a:defRPr sz="2250" b="1">
                 <a:solidFill>
                   <a:srgbClr val="152A43"/>
@@ -3774,6 +3826,7 @@
               </a:defRPr>
             </a:lvl7pPr>
             <a:lvl8pPr>
+              <a:buNone/>
               <a:defRPr sz="2250" b="1">
                 <a:solidFill>
                   <a:srgbClr val="152A43"/>
@@ -3784,6 +3837,7 @@
               </a:defRPr>
             </a:lvl8pPr>
             <a:lvl9pPr>
+              <a:buNone/>
               <a:defRPr sz="2250" b="1">
                 <a:solidFill>
                   <a:srgbClr val="152A43"/>
@@ -3796,6 +3850,7 @@
           </a:lstStyle>
           <a:p xmlns:a="http://schemas.openxmlformats.org/drawingml/2006/main">
             <a:pPr>
+              <a:buNone/>
               <a:defRPr sz="2250" b="1">
                 <a:solidFill>
                   <a:srgbClr val="152A43"/>
@@ -3860,6 +3915,7 @@
               </a:defRPr>
             </a:defPPr>
             <a:lvl1pPr>
+              <a:buNone/>
               <a:defRPr sz="2100" b="0">
                 <a:solidFill>
                   <a:srgbClr val="152A43"/>
@@ -3870,6 +3926,7 @@
               </a:defRPr>
             </a:lvl1pPr>
             <a:lvl2pPr>
+              <a:buNone/>
               <a:defRPr sz="2100" b="0">
                 <a:solidFill>
                   <a:srgbClr val="152A43"/>
@@ -3880,6 +3937,7 @@
               </a:defRPr>
             </a:lvl2pPr>
             <a:lvl3pPr>
+              <a:buNone/>
               <a:defRPr sz="2100" b="0">
                 <a:solidFill>
                   <a:srgbClr val="152A43"/>
@@ -3890,6 +3948,7 @@
               </a:defRPr>
             </a:lvl3pPr>
             <a:lvl4pPr>
+              <a:buNone/>
               <a:defRPr sz="2100" b="0">
                 <a:solidFill>
                   <a:srgbClr val="152A43"/>
@@ -3900,6 +3959,7 @@
               </a:defRPr>
             </a:lvl4pPr>
             <a:lvl5pPr>
+              <a:buNone/>
               <a:defRPr sz="2100" b="0">
                 <a:solidFill>
                   <a:srgbClr val="152A43"/>
@@ -3910,6 +3970,7 @@
               </a:defRPr>
             </a:lvl5pPr>
             <a:lvl6pPr>
+              <a:buNone/>
               <a:defRPr sz="2100" b="0">
                 <a:solidFill>
                   <a:srgbClr val="152A43"/>
@@ -3920,6 +3981,7 @@
               </a:defRPr>
             </a:lvl6pPr>
             <a:lvl7pPr>
+              <a:buNone/>
               <a:defRPr sz="2100" b="0">
                 <a:solidFill>
                   <a:srgbClr val="152A43"/>
@@ -3930,6 +3992,7 @@
               </a:defRPr>
             </a:lvl7pPr>
             <a:lvl8pPr>
+              <a:buNone/>
               <a:defRPr sz="2100" b="0">
                 <a:solidFill>
                   <a:srgbClr val="152A43"/>
@@ -3940,6 +4003,7 @@
               </a:defRPr>
             </a:lvl8pPr>
             <a:lvl9pPr>
+              <a:buNone/>
               <a:defRPr sz="2100" b="0">
                 <a:solidFill>
                   <a:srgbClr val="152A43"/>
@@ -3952,6 +4016,7 @@
           </a:lstStyle>
           <a:p xmlns:a="http://schemas.openxmlformats.org/drawingml/2006/main">
             <a:pPr>
+              <a:buNone/>
               <a:defRPr sz="2100" b="0">
                 <a:solidFill>
                   <a:srgbClr val="152A43"/>
@@ -3975,6 +4040,7 @@
           </a:p>
           <a:p xmlns:a="http://schemas.openxmlformats.org/drawingml/2006/main">
             <a:pPr>
+              <a:buNone/>
               <a:defRPr sz="2100" b="0">
                 <a:solidFill>
                   <a:srgbClr val="152A43"/>
@@ -3998,6 +4064,7 @@
           </a:p>
           <a:p xmlns:a="http://schemas.openxmlformats.org/drawingml/2006/main">
             <a:pPr>
+              <a:buNone/>
               <a:defRPr sz="2100" b="0">
                 <a:solidFill>
                   <a:srgbClr val="152A43"/>
@@ -4021,6 +4088,7 @@
           </a:p>
           <a:p xmlns:a="http://schemas.openxmlformats.org/drawingml/2006/main">
             <a:pPr>
+              <a:buNone/>
               <a:defRPr sz="2100" b="0">
                 <a:solidFill>
                   <a:srgbClr val="152A43"/>
@@ -4085,6 +4153,7 @@
               </a:defRPr>
             </a:defPPr>
             <a:lvl1pPr>
+              <a:buNone/>
               <a:defRPr sz="2250" b="1">
                 <a:solidFill>
                   <a:srgbClr val="152A43"/>
@@ -4095,6 +4164,7 @@
               </a:defRPr>
             </a:lvl1pPr>
             <a:lvl2pPr>
+              <a:buNone/>
               <a:defRPr sz="2250" b="1">
                 <a:solidFill>
                   <a:srgbClr val="152A43"/>
@@ -4105,6 +4175,7 @@
               </a:defRPr>
             </a:lvl2pPr>
             <a:lvl3pPr>
+              <a:buNone/>
               <a:defRPr sz="2250" b="1">
                 <a:solidFill>
                   <a:srgbClr val="152A43"/>
@@ -4115,6 +4186,7 @@
               </a:defRPr>
             </a:lvl3pPr>
             <a:lvl4pPr>
+              <a:buNone/>
               <a:defRPr sz="2250" b="1">
                 <a:solidFill>
                   <a:srgbClr val="152A43"/>
@@ -4125,6 +4197,7 @@
               </a:defRPr>
             </a:lvl4pPr>
             <a:lvl5pPr>
+              <a:buNone/>
               <a:defRPr sz="2250" b="1">
                 <a:solidFill>
                   <a:srgbClr val="152A43"/>
@@ -4135,6 +4208,7 @@
               </a:defRPr>
             </a:lvl5pPr>
             <a:lvl6pPr>
+              <a:buNone/>
               <a:defRPr sz="2250" b="1">
                 <a:solidFill>
                   <a:srgbClr val="152A43"/>
@@ -4145,6 +4219,7 @@
               </a:defRPr>
             </a:lvl6pPr>
             <a:lvl7pPr>
+              <a:buNone/>
               <a:defRPr sz="2250" b="1">
                 <a:solidFill>
                   <a:srgbClr val="152A43"/>
@@ -4155,6 +4230,7 @@
               </a:defRPr>
             </a:lvl7pPr>
             <a:lvl8pPr>
+              <a:buNone/>
               <a:defRPr sz="2250" b="1">
                 <a:solidFill>
                   <a:srgbClr val="152A43"/>
@@ -4165,6 +4241,7 @@
               </a:defRPr>
             </a:lvl8pPr>
             <a:lvl9pPr>
+              <a:buNone/>
               <a:defRPr sz="2250" b="1">
                 <a:solidFill>
                   <a:srgbClr val="152A43"/>
@@ -4177,6 +4254,7 @@
           </a:lstStyle>
           <a:p xmlns:a="http://schemas.openxmlformats.org/drawingml/2006/main">
             <a:pPr>
+              <a:buNone/>
               <a:defRPr sz="2250" b="1">
                 <a:solidFill>
                   <a:srgbClr val="152A43"/>
@@ -4241,6 +4319,7 @@
               </a:defRPr>
             </a:defPPr>
             <a:lvl1pPr>
+              <a:buNone/>
               <a:defRPr sz="2100" b="0">
                 <a:solidFill>
                   <a:srgbClr val="152A43"/>
@@ -4251,6 +4330,7 @@
               </a:defRPr>
             </a:lvl1pPr>
             <a:lvl2pPr>
+              <a:buNone/>
               <a:defRPr sz="2100" b="0">
                 <a:solidFill>
                   <a:srgbClr val="152A43"/>
@@ -4261,6 +4341,7 @@
               </a:defRPr>
             </a:lvl2pPr>
             <a:lvl3pPr>
+              <a:buNone/>
               <a:defRPr sz="2100" b="0">
                 <a:solidFill>
                   <a:srgbClr val="152A43"/>
@@ -4271,6 +4352,7 @@
               </a:defRPr>
             </a:lvl3pPr>
             <a:lvl4pPr>
+              <a:buNone/>
               <a:defRPr sz="2100" b="0">
                 <a:solidFill>
                   <a:srgbClr val="152A43"/>
@@ -4281,6 +4363,7 @@
               </a:defRPr>
             </a:lvl4pPr>
             <a:lvl5pPr>
+              <a:buNone/>
               <a:defRPr sz="2100" b="0">
                 <a:solidFill>
                   <a:srgbClr val="152A43"/>
@@ -4291,6 +4374,7 @@
               </a:defRPr>
             </a:lvl5pPr>
             <a:lvl6pPr>
+              <a:buNone/>
               <a:defRPr sz="2100" b="0">
                 <a:solidFill>
                   <a:srgbClr val="152A43"/>
@@ -4301,6 +4385,7 @@
               </a:defRPr>
             </a:lvl6pPr>
             <a:lvl7pPr>
+              <a:buNone/>
               <a:defRPr sz="2100" b="0">
                 <a:solidFill>
                   <a:srgbClr val="152A43"/>
@@ -4311,6 +4396,7 @@
               </a:defRPr>
             </a:lvl7pPr>
             <a:lvl8pPr>
+              <a:buNone/>
               <a:defRPr sz="2100" b="0">
                 <a:solidFill>
                   <a:srgbClr val="152A43"/>
@@ -4321,6 +4407,7 @@
               </a:defRPr>
             </a:lvl8pPr>
             <a:lvl9pPr>
+              <a:buNone/>
               <a:defRPr sz="2100" b="0">
                 <a:solidFill>
                   <a:srgbClr val="152A43"/>
@@ -4333,6 +4420,7 @@
           </a:lstStyle>
           <a:p xmlns:a="http://schemas.openxmlformats.org/drawingml/2006/main">
             <a:pPr>
+              <a:buNone/>
               <a:defRPr sz="2100" b="0">
                 <a:solidFill>
                   <a:srgbClr val="152A43"/>
@@ -4356,6 +4444,7 @@
           </a:p>
           <a:p xmlns:a="http://schemas.openxmlformats.org/drawingml/2006/main">
             <a:pPr>
+              <a:buNone/>
               <a:defRPr sz="2100" b="0">
                 <a:solidFill>
                   <a:srgbClr val="152A43"/>
@@ -4379,6 +4468,7 @@
           </a:p>
           <a:p xmlns:a="http://schemas.openxmlformats.org/drawingml/2006/main">
             <a:pPr>
+              <a:buNone/>
               <a:defRPr sz="2100" b="0">
                 <a:solidFill>
                   <a:srgbClr val="152A43"/>
@@ -4443,6 +4533,7 @@
               </a:defRPr>
             </a:defPPr>
             <a:lvl1pPr>
+              <a:buNone/>
               <a:defRPr sz="2250" b="1">
                 <a:solidFill>
                   <a:srgbClr val="152A43"/>
@@ -4453,6 +4544,7 @@
               </a:defRPr>
             </a:lvl1pPr>
             <a:lvl2pPr>
+              <a:buNone/>
               <a:defRPr sz="2250" b="1">
                 <a:solidFill>
                   <a:srgbClr val="152A43"/>
@@ -4463,6 +4555,7 @@
               </a:defRPr>
             </a:lvl2pPr>
             <a:lvl3pPr>
+              <a:buNone/>
               <a:defRPr sz="2250" b="1">
                 <a:solidFill>
                   <a:srgbClr val="152A43"/>
@@ -4473,6 +4566,7 @@
               </a:defRPr>
             </a:lvl3pPr>
             <a:lvl4pPr>
+              <a:buNone/>
               <a:defRPr sz="2250" b="1">
                 <a:solidFill>
                   <a:srgbClr val="152A43"/>
@@ -4483,6 +4577,7 @@
               </a:defRPr>
             </a:lvl4pPr>
             <a:lvl5pPr>
+              <a:buNone/>
               <a:defRPr sz="2250" b="1">
                 <a:solidFill>
                   <a:srgbClr val="152A43"/>
@@ -4493,6 +4588,7 @@
               </a:defRPr>
             </a:lvl5pPr>
             <a:lvl6pPr>
+              <a:buNone/>
               <a:defRPr sz="2250" b="1">
                 <a:solidFill>
                   <a:srgbClr val="152A43"/>
@@ -4503,6 +4599,7 @@
               </a:defRPr>
             </a:lvl6pPr>
             <a:lvl7pPr>
+              <a:buNone/>
               <a:defRPr sz="2250" b="1">
                 <a:solidFill>
                   <a:srgbClr val="152A43"/>
@@ -4513,6 +4610,7 @@
               </a:defRPr>
             </a:lvl7pPr>
             <a:lvl8pPr>
+              <a:buNone/>
               <a:defRPr sz="2250" b="1">
                 <a:solidFill>
                   <a:srgbClr val="152A43"/>
@@ -4523,6 +4621,7 @@
               </a:defRPr>
             </a:lvl8pPr>
             <a:lvl9pPr>
+              <a:buNone/>
               <a:defRPr sz="2250" b="1">
                 <a:solidFill>
                   <a:srgbClr val="152A43"/>
@@ -4535,6 +4634,7 @@
           </a:lstStyle>
           <a:p xmlns:a="http://schemas.openxmlformats.org/drawingml/2006/main">
             <a:pPr>
+              <a:buNone/>
               <a:defRPr sz="2250" b="1">
                 <a:solidFill>
                   <a:srgbClr val="152A43"/>
@@ -4589,7 +4689,7 @@
           <a:bodyPr xmlns:a="http://schemas.openxmlformats.org/drawingml/2006/main"/>
           <a:lstStyle xmlns:a="http://schemas.openxmlformats.org/drawingml/2006/main">
             <a:defPPr>
-              <a:defRPr sz="2100" b="0">
+              <a:defRPr sz="1950" b="0">
                 <a:solidFill>
                   <a:srgbClr val="152A43"/>
                 </a:solidFill>
@@ -4599,6 +4699,7 @@
               </a:defRPr>
             </a:defPPr>
             <a:lvl1pPr>
+              <a:buNone/>
               <a:defRPr sz="2100" b="0">
                 <a:solidFill>
                   <a:srgbClr val="152A43"/>
@@ -4609,6 +4710,7 @@
               </a:defRPr>
             </a:lvl1pPr>
             <a:lvl2pPr>
+              <a:buNone/>
               <a:defRPr sz="2100" b="0">
                 <a:solidFill>
                   <a:srgbClr val="152A43"/>
@@ -4619,6 +4721,7 @@
               </a:defRPr>
             </a:lvl2pPr>
             <a:lvl3pPr>
+              <a:buNone/>
               <a:defRPr sz="2100" b="0">
                 <a:solidFill>
                   <a:srgbClr val="152A43"/>
@@ -4629,6 +4732,7 @@
               </a:defRPr>
             </a:lvl3pPr>
             <a:lvl4pPr>
+              <a:buNone/>
               <a:defRPr sz="2100" b="0">
                 <a:solidFill>
                   <a:srgbClr val="152A43"/>
@@ -4639,6 +4743,7 @@
               </a:defRPr>
             </a:lvl4pPr>
             <a:lvl5pPr>
+              <a:buNone/>
               <a:defRPr sz="2100" b="0">
                 <a:solidFill>
                   <a:srgbClr val="152A43"/>
@@ -4649,6 +4754,7 @@
               </a:defRPr>
             </a:lvl5pPr>
             <a:lvl6pPr>
+              <a:buNone/>
               <a:defRPr sz="2100" b="0">
                 <a:solidFill>
                   <a:srgbClr val="152A43"/>
@@ -4659,6 +4765,7 @@
               </a:defRPr>
             </a:lvl6pPr>
             <a:lvl7pPr>
+              <a:buNone/>
               <a:defRPr sz="2100" b="0">
                 <a:solidFill>
                   <a:srgbClr val="152A43"/>
@@ -4669,6 +4776,7 @@
               </a:defRPr>
             </a:lvl7pPr>
             <a:lvl8pPr>
+              <a:buNone/>
               <a:defRPr sz="2100" b="0">
                 <a:solidFill>
                   <a:srgbClr val="152A43"/>
@@ -4679,6 +4787,7 @@
               </a:defRPr>
             </a:lvl8pPr>
             <a:lvl9pPr>
+              <a:buNone/>
               <a:defRPr sz="2100" b="0">
                 <a:solidFill>
                   <a:srgbClr val="152A43"/>
@@ -4691,7 +4800,8 @@
           </a:lstStyle>
           <a:p xmlns:a="http://schemas.openxmlformats.org/drawingml/2006/main">
             <a:pPr>
-              <a:defRPr sz="2100" b="0">
+              <a:buNone/>
+              <a:defRPr sz="1950" b="0">
                 <a:solidFill>
                   <a:srgbClr val="152A43"/>
                 </a:solidFill>
@@ -4701,7 +4811,7 @@
               </a:defRPr>
             </a:pPr>
             <a:r>
-              <a:rPr sz="2100" b="0">
+              <a:rPr sz="1950" b="0">
                 <a:solidFill>
                   <a:srgbClr val="152A43"/>
                 </a:solidFill>
@@ -4709,12 +4819,13 @@
                 <a:ea typeface="Arial"/>
                 <a:cs typeface="Arial"/>
               </a:rPr>
-              <a:t>Export the official trajectory, including the final evaluation.</a:t>
+              <a:t>Export each official trajectory, including the final evaluation.</a:t>
             </a:r>
           </a:p>
           <a:p xmlns:a="http://schemas.openxmlformats.org/drawingml/2006/main">
             <a:pPr>
-              <a:defRPr sz="2100" b="0">
+              <a:buNone/>
+              <a:defRPr sz="1950" b="0">
                 <a:solidFill>
                   <a:srgbClr val="152A43"/>
                 </a:solidFill>
@@ -4724,7 +4835,7 @@
               </a:defRPr>
             </a:pPr>
             <a:r>
-              <a:rPr sz="2100" b="0">
+              <a:rPr sz="1950" b="0">
                 <a:solidFill>
                   <a:srgbClr val="152A43"/>
                 </a:solidFill>
@@ -4732,7 +4843,7 @@
                 <a:ea typeface="Arial"/>
                 <a:cs typeface="Arial"/>
               </a:rPr>
-              <a:t>Online logs support diagnostics and do not replace the complete trajectory.</a:t>
+              <a:t>Generator/filter audit logs remain separate from decision inputs.</a:t>
             </a:r>
           </a:p>
         </p:txBody>
@@ -4778,6 +4889,7 @@
               </a:defRPr>
             </a:defPPr>
             <a:lvl1pPr>
+              <a:buNone/>
               <a:defRPr sz="1725" b="0">
                 <a:solidFill>
                   <a:srgbClr val="5B6470"/>
@@ -4788,6 +4900,7 @@
               </a:defRPr>
             </a:lvl1pPr>
             <a:lvl2pPr>
+              <a:buNone/>
               <a:defRPr sz="1725" b="0">
                 <a:solidFill>
                   <a:srgbClr val="5B6470"/>
@@ -4798,6 +4911,7 @@
               </a:defRPr>
             </a:lvl2pPr>
             <a:lvl3pPr>
+              <a:buNone/>
               <a:defRPr sz="1725" b="0">
                 <a:solidFill>
                   <a:srgbClr val="5B6470"/>
@@ -4808,6 +4922,7 @@
               </a:defRPr>
             </a:lvl3pPr>
             <a:lvl4pPr>
+              <a:buNone/>
               <a:defRPr sz="1725" b="0">
                 <a:solidFill>
                   <a:srgbClr val="5B6470"/>
@@ -4818,6 +4933,7 @@
               </a:defRPr>
             </a:lvl4pPr>
             <a:lvl5pPr>
+              <a:buNone/>
               <a:defRPr sz="1725" b="0">
                 <a:solidFill>
                   <a:srgbClr val="5B6470"/>
@@ -4828,6 +4944,7 @@
               </a:defRPr>
             </a:lvl5pPr>
             <a:lvl6pPr>
+              <a:buNone/>
               <a:defRPr sz="1725" b="0">
                 <a:solidFill>
                   <a:srgbClr val="5B6470"/>
@@ -4838,6 +4955,7 @@
               </a:defRPr>
             </a:lvl6pPr>
             <a:lvl7pPr>
+              <a:buNone/>
               <a:defRPr sz="1725" b="0">
                 <a:solidFill>
                   <a:srgbClr val="5B6470"/>
@@ -4848,6 +4966,7 @@
               </a:defRPr>
             </a:lvl7pPr>
             <a:lvl8pPr>
+              <a:buNone/>
               <a:defRPr sz="1725" b="0">
                 <a:solidFill>
                   <a:srgbClr val="5B6470"/>
@@ -4858,6 +4977,7 @@
               </a:defRPr>
             </a:lvl8pPr>
             <a:lvl9pPr>
+              <a:buNone/>
               <a:defRPr sz="1725" b="0">
                 <a:solidFill>
                   <a:srgbClr val="5B6470"/>
@@ -4870,6 +4990,7 @@
           </a:lstStyle>
           <a:p xmlns:a="http://schemas.openxmlformats.org/drawingml/2006/main">
             <a:pPr>
+              <a:buNone/>
               <a:defRPr sz="1725" b="0">
                 <a:solidFill>
                   <a:srgbClr val="5B6470"/>
@@ -4888,7 +5009,7 @@
                 <a:ea typeface="Arial"/>
                 <a:cs typeface="Arial"/>
               </a:rPr>
-              <a:t>M4 interface is available. Planner consumption remains pending.</a:t>
+              <a:t>M1 capture adopted. M3 consumes memory. Draft updated 21 Oct 2026.</a:t>
             </a:r>
           </a:p>
         </p:txBody>
@@ -4963,6 +5084,7 @@
               </a:defRPr>
             </a:defPPr>
             <a:lvl1pPr>
+              <a:buNone/>
               <a:defRPr sz="3600" b="1">
                 <a:solidFill>
                   <a:srgbClr val="152A43"/>
@@ -4973,6 +5095,7 @@
               </a:defRPr>
             </a:lvl1pPr>
             <a:lvl2pPr>
+              <a:buNone/>
               <a:defRPr sz="3600" b="1">
                 <a:solidFill>
                   <a:srgbClr val="152A43"/>
@@ -4983,6 +5106,7 @@
               </a:defRPr>
             </a:lvl2pPr>
             <a:lvl3pPr>
+              <a:buNone/>
               <a:defRPr sz="3600" b="1">
                 <a:solidFill>
                   <a:srgbClr val="152A43"/>
@@ -4993,6 +5117,7 @@
               </a:defRPr>
             </a:lvl3pPr>
             <a:lvl4pPr>
+              <a:buNone/>
               <a:defRPr sz="3600" b="1">
                 <a:solidFill>
                   <a:srgbClr val="152A43"/>
@@ -5003,6 +5128,7 @@
               </a:defRPr>
             </a:lvl4pPr>
             <a:lvl5pPr>
+              <a:buNone/>
               <a:defRPr sz="3600" b="1">
                 <a:solidFill>
                   <a:srgbClr val="152A43"/>
@@ -5013,6 +5139,7 @@
               </a:defRPr>
             </a:lvl5pPr>
             <a:lvl6pPr>
+              <a:buNone/>
               <a:defRPr sz="3600" b="1">
                 <a:solidFill>
                   <a:srgbClr val="152A43"/>
@@ -5023,6 +5150,7 @@
               </a:defRPr>
             </a:lvl6pPr>
             <a:lvl7pPr>
+              <a:buNone/>
               <a:defRPr sz="3600" b="1">
                 <a:solidFill>
                   <a:srgbClr val="152A43"/>
@@ -5033,6 +5161,7 @@
               </a:defRPr>
             </a:lvl7pPr>
             <a:lvl8pPr>
+              <a:buNone/>
               <a:defRPr sz="3600" b="1">
                 <a:solidFill>
                   <a:srgbClr val="152A43"/>
@@ -5043,6 +5172,7 @@
               </a:defRPr>
             </a:lvl8pPr>
             <a:lvl9pPr>
+              <a:buNone/>
               <a:defRPr sz="3600" b="1">
                 <a:solidFill>
                   <a:srgbClr val="152A43"/>
@@ -5055,6 +5185,7 @@
           </a:lstStyle>
           <a:p xmlns:a="http://schemas.openxmlformats.org/drawingml/2006/main">
             <a:pPr>
+              <a:buNone/>
               <a:defRPr sz="3600" b="1">
                 <a:solidFill>
                   <a:srgbClr val="152A43"/>
@@ -5073,7 +5204,7 @@
                 <a:ea typeface="Arial"/>
                 <a:cs typeface="Arial"/>
               </a:rPr>
-              <a:t>Workflow validation and planned ablation</a:t>
+              <a:t>Memory pilot and planned evaluation</a:t>
             </a:r>
           </a:p>
         </p:txBody>
@@ -5083,7 +5214,7 @@
           <p:cNvPr id="2" name="">
             <a:extLst xmlns:a="http://schemas.openxmlformats.org/drawingml/2006/main">
               <a:ext uri="{FF2B5EF4-FFF2-40B4-BE49-F238E27FC236}">
-                <a16:creationId xmlns:a16="http://schemas.microsoft.com/office/drawing/2014/main" id="{05778845-1CB3-4243-8022-47A9B173FC3A}"/>
+                <a16:creationId xmlns:a16="http://schemas.microsoft.com/office/drawing/2014/main" id="{749DC283-89B5-405E-AA5B-77AAAD8356B9}"/>
               </a:ext>
             </a:extLst>
           </p:cNvPr>
@@ -5093,7 +5224,7 @@
           <p:nvPr/>
         </p:nvPicPr>
         <p:blipFill>
-          <a:blip xmlns:r="http://schemas.openxmlformats.org/officeDocument/2006/relationships" xmlns:a="http://schemas.openxmlformats.org/drawingml/2006/main" r:embed="R4034af7af0dd41a8"/>
+          <a:blip xmlns:r="http://schemas.openxmlformats.org/officeDocument/2006/relationships" xmlns:a="http://schemas.openxmlformats.org/drawingml/2006/main" r:embed="Rea2d3ebf58d447cf"/>
           <a:stretch xmlns:a="http://schemas.openxmlformats.org/drawingml/2006/main"/>
         </p:blipFill>
         <p:spPr>
@@ -5147,6 +5278,7 @@
               </a:defRPr>
             </a:defPPr>
             <a:lvl1pPr>
+              <a:buNone/>
               <a:defRPr sz="1950" b="1">
                 <a:solidFill>
                   <a:srgbClr val="152A43"/>
@@ -5157,6 +5289,7 @@
               </a:defRPr>
             </a:lvl1pPr>
             <a:lvl2pPr>
+              <a:buNone/>
               <a:defRPr sz="1950" b="1">
                 <a:solidFill>
                   <a:srgbClr val="152A43"/>
@@ -5167,6 +5300,7 @@
               </a:defRPr>
             </a:lvl2pPr>
             <a:lvl3pPr>
+              <a:buNone/>
               <a:defRPr sz="1950" b="1">
                 <a:solidFill>
                   <a:srgbClr val="152A43"/>
@@ -5177,6 +5311,7 @@
               </a:defRPr>
             </a:lvl3pPr>
             <a:lvl4pPr>
+              <a:buNone/>
               <a:defRPr sz="1950" b="1">
                 <a:solidFill>
                   <a:srgbClr val="152A43"/>
@@ -5187,6 +5322,7 @@
               </a:defRPr>
             </a:lvl4pPr>
             <a:lvl5pPr>
+              <a:buNone/>
               <a:defRPr sz="1950" b="1">
                 <a:solidFill>
                   <a:srgbClr val="152A43"/>
@@ -5197,6 +5333,7 @@
               </a:defRPr>
             </a:lvl5pPr>
             <a:lvl6pPr>
+              <a:buNone/>
               <a:defRPr sz="1950" b="1">
                 <a:solidFill>
                   <a:srgbClr val="152A43"/>
@@ -5207,6 +5344,7 @@
               </a:defRPr>
             </a:lvl6pPr>
             <a:lvl7pPr>
+              <a:buNone/>
               <a:defRPr sz="1950" b="1">
                 <a:solidFill>
                   <a:srgbClr val="152A43"/>
@@ -5217,6 +5355,7 @@
               </a:defRPr>
             </a:lvl7pPr>
             <a:lvl8pPr>
+              <a:buNone/>
               <a:defRPr sz="1950" b="1">
                 <a:solidFill>
                   <a:srgbClr val="152A43"/>
@@ -5227,6 +5366,7 @@
               </a:defRPr>
             </a:lvl8pPr>
             <a:lvl9pPr>
+              <a:buNone/>
               <a:defRPr sz="1950" b="1">
                 <a:solidFill>
                   <a:srgbClr val="152A43"/>
@@ -5239,6 +5379,7 @@
           </a:lstStyle>
           <a:p xmlns:a="http://schemas.openxmlformats.org/drawingml/2006/main">
             <a:pPr>
+              <a:buNone/>
               <a:defRPr sz="1950" b="1">
                 <a:solidFill>
                   <a:srgbClr val="152A43"/>
@@ -5257,7 +5398,7 @@
                 <a:ea typeface="Arial"/>
                 <a:cs typeface="Arial"/>
               </a:rPr>
-              <a:t>Mg-Sn-Sr workflow validation</a:t>
+              <a:t>Memory ON observed phase diagram</a:t>
             </a:r>
           </a:p>
         </p:txBody>
@@ -5303,6 +5444,7 @@
               </a:defRPr>
             </a:defPPr>
             <a:lvl1pPr>
+              <a:buNone/>
               <a:defRPr sz="1725" b="0">
                 <a:solidFill>
                   <a:srgbClr val="152A43"/>
@@ -5313,6 +5455,7 @@
               </a:defRPr>
             </a:lvl1pPr>
             <a:lvl2pPr>
+              <a:buNone/>
               <a:defRPr sz="1725" b="0">
                 <a:solidFill>
                   <a:srgbClr val="152A43"/>
@@ -5323,6 +5466,7 @@
               </a:defRPr>
             </a:lvl2pPr>
             <a:lvl3pPr>
+              <a:buNone/>
               <a:defRPr sz="1725" b="0">
                 <a:solidFill>
                   <a:srgbClr val="152A43"/>
@@ -5333,6 +5477,7 @@
               </a:defRPr>
             </a:lvl3pPr>
             <a:lvl4pPr>
+              <a:buNone/>
               <a:defRPr sz="1725" b="0">
                 <a:solidFill>
                   <a:srgbClr val="152A43"/>
@@ -5343,6 +5488,7 @@
               </a:defRPr>
             </a:lvl4pPr>
             <a:lvl5pPr>
+              <a:buNone/>
               <a:defRPr sz="1725" b="0">
                 <a:solidFill>
                   <a:srgbClr val="152A43"/>
@@ -5353,6 +5499,7 @@
               </a:defRPr>
             </a:lvl5pPr>
             <a:lvl6pPr>
+              <a:buNone/>
               <a:defRPr sz="1725" b="0">
                 <a:solidFill>
                   <a:srgbClr val="152A43"/>
@@ -5363,6 +5510,7 @@
               </a:defRPr>
             </a:lvl6pPr>
             <a:lvl7pPr>
+              <a:buNone/>
               <a:defRPr sz="1725" b="0">
                 <a:solidFill>
                   <a:srgbClr val="152A43"/>
@@ -5373,6 +5521,7 @@
               </a:defRPr>
             </a:lvl7pPr>
             <a:lvl8pPr>
+              <a:buNone/>
               <a:defRPr sz="1725" b="0">
                 <a:solidFill>
                   <a:srgbClr val="152A43"/>
@@ -5383,6 +5532,7 @@
               </a:defRPr>
             </a:lvl8pPr>
             <a:lvl9pPr>
+              <a:buNone/>
               <a:defRPr sz="1725" b="0">
                 <a:solidFill>
                   <a:srgbClr val="152A43"/>
@@ -5395,6 +5545,7 @@
           </a:lstStyle>
           <a:p xmlns:a="http://schemas.openxmlformats.org/drawingml/2006/main">
             <a:pPr>
+              <a:buNone/>
               <a:defRPr sz="1725" b="0">
                 <a:solidFill>
                   <a:srgbClr val="152A43"/>
@@ -5413,11 +5564,12 @@
                 <a:ea typeface="Arial"/>
                 <a:cs typeface="Arial"/>
               </a:rPr>
-              <a:t>CPU ORB, seed 17, 20 campaign queries</a:t>
+              <a:t>CPU ORB, seed 17, B=20 per arm</a:t>
             </a:r>
           </a:p>
           <a:p xmlns:a="http://schemas.openxmlformats.org/drawingml/2006/main">
             <a:pPr>
+              <a:buNone/>
               <a:defRPr sz="1725" b="0">
                 <a:solidFill>
                   <a:srgbClr val="152A43"/>
@@ -5436,7 +5588,7 @@
                 <a:ea typeface="Arial"/>
                 <a:cs typeface="Arial"/>
               </a:rPr>
-              <a:t>157.193 seconds, including first-run setup</a:t>
+              <a:t>M3/M4 pilot, exploration and routing off</a:t>
             </a:r>
           </a:p>
         </p:txBody>
@@ -5482,6 +5634,7 @@
               </a:defRPr>
             </a:defPPr>
             <a:lvl1pPr>
+              <a:buNone/>
               <a:defRPr sz="2325" b="1">
                 <a:solidFill>
                   <a:srgbClr val="152A43"/>
@@ -5492,6 +5645,7 @@
               </a:defRPr>
             </a:lvl1pPr>
             <a:lvl2pPr>
+              <a:buNone/>
               <a:defRPr sz="2325" b="1">
                 <a:solidFill>
                   <a:srgbClr val="152A43"/>
@@ -5502,6 +5656,7 @@
               </a:defRPr>
             </a:lvl2pPr>
             <a:lvl3pPr>
+              <a:buNone/>
               <a:defRPr sz="2325" b="1">
                 <a:solidFill>
                   <a:srgbClr val="152A43"/>
@@ -5512,6 +5667,7 @@
               </a:defRPr>
             </a:lvl3pPr>
             <a:lvl4pPr>
+              <a:buNone/>
               <a:defRPr sz="2325" b="1">
                 <a:solidFill>
                   <a:srgbClr val="152A43"/>
@@ -5522,6 +5678,7 @@
               </a:defRPr>
             </a:lvl4pPr>
             <a:lvl5pPr>
+              <a:buNone/>
               <a:defRPr sz="2325" b="1">
                 <a:solidFill>
                   <a:srgbClr val="152A43"/>
@@ -5532,6 +5689,7 @@
               </a:defRPr>
             </a:lvl5pPr>
             <a:lvl6pPr>
+              <a:buNone/>
               <a:defRPr sz="2325" b="1">
                 <a:solidFill>
                   <a:srgbClr val="152A43"/>
@@ -5542,6 +5700,7 @@
               </a:defRPr>
             </a:lvl6pPr>
             <a:lvl7pPr>
+              <a:buNone/>
               <a:defRPr sz="2325" b="1">
                 <a:solidFill>
                   <a:srgbClr val="152A43"/>
@@ -5552,6 +5711,7 @@
               </a:defRPr>
             </a:lvl7pPr>
             <a:lvl8pPr>
+              <a:buNone/>
               <a:defRPr sz="2325" b="1">
                 <a:solidFill>
                   <a:srgbClr val="152A43"/>
@@ -5562,6 +5722,7 @@
               </a:defRPr>
             </a:lvl8pPr>
             <a:lvl9pPr>
+              <a:buNone/>
               <a:defRPr sz="2325" b="1">
                 <a:solidFill>
                   <a:srgbClr val="152A43"/>
@@ -5574,6 +5735,7 @@
           </a:lstStyle>
           <a:p xmlns:a="http://schemas.openxmlformats.org/drawingml/2006/main">
             <a:pPr>
+              <a:buNone/>
               <a:defRPr sz="2325" b="1">
                 <a:solidFill>
                   <a:srgbClr val="152A43"/>
@@ -5592,232 +5754,7 @@
                 <a:ea typeface="Arial"/>
                 <a:cs typeface="Arial"/>
               </a:rPr>
-              <a:t>Completed</a:t>
-            </a:r>
-          </a:p>
-        </p:txBody>
-      </p:sp>
-      <p:sp>
-        <p:nvSpPr>
-          <p:cNvPr id="6" name="">
-            <a:extLst xmlns:a="http://schemas.openxmlformats.org/drawingml/2006/main">
-              <a:ext uri="{FF2B5EF4-FFF2-40B4-BE49-F238E27FC236}">
-                <a16:creationId xmlns:a16="http://schemas.microsoft.com/office/drawing/2014/main" id="{DFA3A249-D3F0-4061-984C-C28D0D5C82CD}"/>
-              </a:ext>
-            </a:extLst>
-          </p:cNvPr>
-          <p:cNvSpPr>
-            <a:spLocks xmlns:a="http://schemas.openxmlformats.org/drawingml/2006/main" noGrp="1"/>
-          </p:cNvSpPr>
-          <p:nvPr/>
-        </p:nvSpPr>
-        <p:spPr>
-          <a:xfrm xmlns:a="http://schemas.openxmlformats.org/drawingml/2006/main">
-            <a:off x="6477000" y="2038350"/>
-            <a:ext cx="5105400" cy="1457325"/>
-          </a:xfrm>
-          <a:prstGeom xmlns:a="http://schemas.openxmlformats.org/drawingml/2006/main" prst="rect">
-            <a:avLst/>
-          </a:prstGeom>
-          <a:noFill xmlns:a="http://schemas.openxmlformats.org/drawingml/2006/main"/>
-          <a:ln xmlns:a="http://schemas.openxmlformats.org/drawingml/2006/main" w="0">
-            <a:noFill/>
-          </a:ln>
-        </p:spPr>
-        <p:txBody>
-          <a:bodyPr xmlns:a="http://schemas.openxmlformats.org/drawingml/2006/main"/>
-          <a:lstStyle xmlns:a="http://schemas.openxmlformats.org/drawingml/2006/main">
-            <a:defPPr>
-              <a:defRPr sz="2025" b="0">
-                <a:solidFill>
-                  <a:srgbClr val="152A43"/>
-                </a:solidFill>
-                <a:latin typeface="Arial"/>
-                <a:ea typeface="Arial"/>
-                <a:cs typeface="Arial"/>
-              </a:defRPr>
-            </a:defPPr>
-            <a:lvl1pPr>
-              <a:defRPr sz="2025" b="0">
-                <a:solidFill>
-                  <a:srgbClr val="152A43"/>
-                </a:solidFill>
-                <a:latin typeface="Arial"/>
-                <a:ea typeface="Arial"/>
-                <a:cs typeface="Arial"/>
-              </a:defRPr>
-            </a:lvl1pPr>
-            <a:lvl2pPr>
-              <a:defRPr sz="2025" b="0">
-                <a:solidFill>
-                  <a:srgbClr val="152A43"/>
-                </a:solidFill>
-                <a:latin typeface="Arial"/>
-                <a:ea typeface="Arial"/>
-                <a:cs typeface="Arial"/>
-              </a:defRPr>
-            </a:lvl2pPr>
-            <a:lvl3pPr>
-              <a:defRPr sz="2025" b="0">
-                <a:solidFill>
-                  <a:srgbClr val="152A43"/>
-                </a:solidFill>
-                <a:latin typeface="Arial"/>
-                <a:ea typeface="Arial"/>
-                <a:cs typeface="Arial"/>
-              </a:defRPr>
-            </a:lvl3pPr>
-            <a:lvl4pPr>
-              <a:defRPr sz="2025" b="0">
-                <a:solidFill>
-                  <a:srgbClr val="152A43"/>
-                </a:solidFill>
-                <a:latin typeface="Arial"/>
-                <a:ea typeface="Arial"/>
-                <a:cs typeface="Arial"/>
-              </a:defRPr>
-            </a:lvl4pPr>
-            <a:lvl5pPr>
-              <a:defRPr sz="2025" b="0">
-                <a:solidFill>
-                  <a:srgbClr val="152A43"/>
-                </a:solidFill>
-                <a:latin typeface="Arial"/>
-                <a:ea typeface="Arial"/>
-                <a:cs typeface="Arial"/>
-              </a:defRPr>
-            </a:lvl5pPr>
-            <a:lvl6pPr>
-              <a:defRPr sz="2025" b="0">
-                <a:solidFill>
-                  <a:srgbClr val="152A43"/>
-                </a:solidFill>
-                <a:latin typeface="Arial"/>
-                <a:ea typeface="Arial"/>
-                <a:cs typeface="Arial"/>
-              </a:defRPr>
-            </a:lvl6pPr>
-            <a:lvl7pPr>
-              <a:defRPr sz="2025" b="0">
-                <a:solidFill>
-                  <a:srgbClr val="152A43"/>
-                </a:solidFill>
-                <a:latin typeface="Arial"/>
-                <a:ea typeface="Arial"/>
-                <a:cs typeface="Arial"/>
-              </a:defRPr>
-            </a:lvl7pPr>
-            <a:lvl8pPr>
-              <a:defRPr sz="2025" b="0">
-                <a:solidFill>
-                  <a:srgbClr val="152A43"/>
-                </a:solidFill>
-                <a:latin typeface="Arial"/>
-                <a:ea typeface="Arial"/>
-                <a:cs typeface="Arial"/>
-              </a:defRPr>
-            </a:lvl8pPr>
-            <a:lvl9pPr>
-              <a:defRPr sz="2025" b="0">
-                <a:solidFill>
-                  <a:srgbClr val="152A43"/>
-                </a:solidFill>
-                <a:latin typeface="Arial"/>
-                <a:ea typeface="Arial"/>
-                <a:cs typeface="Arial"/>
-              </a:defRPr>
-            </a:lvl9pPr>
-          </a:lstStyle>
-          <a:p xmlns:a="http://schemas.openxmlformats.org/drawingml/2006/main">
-            <a:pPr>
-              <a:defRPr sz="2025" b="0">
-                <a:solidFill>
-                  <a:srgbClr val="152A43"/>
-                </a:solidFill>
-                <a:latin typeface="Arial"/>
-                <a:ea typeface="Arial"/>
-                <a:cs typeface="Arial"/>
-              </a:defRPr>
-            </a:pPr>
-            <a:r>
-              <a:rPr sz="2025" b="0">
-                <a:solidFill>
-                  <a:srgbClr val="152A43"/>
-                </a:solidFill>
-                <a:latin typeface="Arial"/>
-                <a:ea typeface="Arial"/>
-                <a:cs typeface="Arial"/>
-              </a:rPr>
-              <a:t>All 20 evaluations exported</a:t>
-            </a:r>
-          </a:p>
-          <a:p xmlns:a="http://schemas.openxmlformats.org/drawingml/2006/main">
-            <a:pPr>
-              <a:defRPr sz="2025" b="0">
-                <a:solidFill>
-                  <a:srgbClr val="152A43"/>
-                </a:solidFill>
-                <a:latin typeface="Arial"/>
-                <a:ea typeface="Arial"/>
-                <a:cs typeface="Arial"/>
-              </a:defRPr>
-            </a:pPr>
-            <a:r>
-              <a:rPr sz="2025" b="0">
-                <a:solidFill>
-                  <a:srgbClr val="152A43"/>
-                </a:solidFill>
-                <a:latin typeface="Arial"/>
-                <a:ea typeface="Arial"/>
-                <a:cs typeface="Arial"/>
-              </a:rPr>
-              <a:t>Final observation retained</a:t>
-            </a:r>
-          </a:p>
-          <a:p xmlns:a="http://schemas.openxmlformats.org/drawingml/2006/main">
-            <a:pPr>
-              <a:defRPr sz="2025" b="0">
-                <a:solidFill>
-                  <a:srgbClr val="152A43"/>
-                </a:solidFill>
-                <a:latin typeface="Arial"/>
-                <a:ea typeface="Arial"/>
-                <a:cs typeface="Arial"/>
-              </a:defRPr>
-            </a:pPr>
-            <a:r>
-              <a:rPr sz="2025" b="0">
-                <a:solidFill>
-                  <a:srgbClr val="152A43"/>
-                </a:solidFill>
-                <a:latin typeface="Arial"/>
-                <a:ea typeface="Arial"/>
-                <a:cs typeface="Arial"/>
-              </a:rPr>
-              <a:t>20 campaign queries exclude</a:t>
-            </a:r>
-          </a:p>
-          <a:p xmlns:a="http://schemas.openxmlformats.org/drawingml/2006/main">
-            <a:pPr>
-              <a:defRPr sz="2025" b="0">
-                <a:solidFill>
-                  <a:srgbClr val="152A43"/>
-                </a:solidFill>
-                <a:latin typeface="Arial"/>
-                <a:ea typeface="Arial"/>
-                <a:cs typeface="Arial"/>
-              </a:defRPr>
-            </a:pPr>
-            <a:r>
-              <a:rPr sz="2025" b="0">
-                <a:solidFill>
-                  <a:srgbClr val="152A43"/>
-                </a:solidFill>
-                <a:latin typeface="Arial"/>
-                <a:ea typeface="Arial"/>
-                <a:cs typeface="Arial"/>
-              </a:rPr>
-              <a:t>additional initialization evaluations</a:t>
+              <a:t>Development comparison</a:t>
             </a:r>
           </a:p>
         </p:txBody>
@@ -5863,6 +5800,7 @@
               </a:defRPr>
             </a:defPPr>
             <a:lvl1pPr>
+              <a:buNone/>
               <a:defRPr sz="2250" b="1">
                 <a:solidFill>
                   <a:srgbClr val="152A43"/>
@@ -5873,6 +5811,7 @@
               </a:defRPr>
             </a:lvl1pPr>
             <a:lvl2pPr>
+              <a:buNone/>
               <a:defRPr sz="2250" b="1">
                 <a:solidFill>
                   <a:srgbClr val="152A43"/>
@@ -5883,6 +5822,7 @@
               </a:defRPr>
             </a:lvl2pPr>
             <a:lvl3pPr>
+              <a:buNone/>
               <a:defRPr sz="2250" b="1">
                 <a:solidFill>
                   <a:srgbClr val="152A43"/>
@@ -5893,6 +5833,7 @@
               </a:defRPr>
             </a:lvl3pPr>
             <a:lvl4pPr>
+              <a:buNone/>
               <a:defRPr sz="2250" b="1">
                 <a:solidFill>
                   <a:srgbClr val="152A43"/>
@@ -5903,6 +5844,7 @@
               </a:defRPr>
             </a:lvl4pPr>
             <a:lvl5pPr>
+              <a:buNone/>
               <a:defRPr sz="2250" b="1">
                 <a:solidFill>
                   <a:srgbClr val="152A43"/>
@@ -5913,6 +5855,7 @@
               </a:defRPr>
             </a:lvl5pPr>
             <a:lvl6pPr>
+              <a:buNone/>
               <a:defRPr sz="2250" b="1">
                 <a:solidFill>
                   <a:srgbClr val="152A43"/>
@@ -5923,6 +5866,7 @@
               </a:defRPr>
             </a:lvl6pPr>
             <a:lvl7pPr>
+              <a:buNone/>
               <a:defRPr sz="2250" b="1">
                 <a:solidFill>
                   <a:srgbClr val="152A43"/>
@@ -5933,6 +5877,7 @@
               </a:defRPr>
             </a:lvl7pPr>
             <a:lvl8pPr>
+              <a:buNone/>
               <a:defRPr sz="2250" b="1">
                 <a:solidFill>
                   <a:srgbClr val="152A43"/>
@@ -5943,6 +5888,7 @@
               </a:defRPr>
             </a:lvl8pPr>
             <a:lvl9pPr>
+              <a:buNone/>
               <a:defRPr sz="2250" b="1">
                 <a:solidFill>
                   <a:srgbClr val="152A43"/>
@@ -5955,6 +5901,7 @@
           </a:lstStyle>
           <a:p xmlns:a="http://schemas.openxmlformats.org/drawingml/2006/main">
             <a:pPr>
+              <a:buNone/>
               <a:defRPr sz="2250" b="1">
                 <a:solidFill>
                   <a:srgbClr val="152A43"/>
@@ -5973,7 +5920,7 @@
                 <a:ea typeface="Arial"/>
                 <a:cs typeface="Arial"/>
               </a:rPr>
-              <a:t>Planned Memory ablation</a:t>
+              <a:t>Interpretation</a:t>
             </a:r>
           </a:p>
         </p:txBody>
@@ -6019,6 +5966,7 @@
               </a:defRPr>
             </a:defPPr>
             <a:lvl1pPr>
+              <a:buNone/>
               <a:defRPr sz="2025" b="0">
                 <a:solidFill>
                   <a:srgbClr val="152A43"/>
@@ -6029,6 +5977,7 @@
               </a:defRPr>
             </a:lvl1pPr>
             <a:lvl2pPr>
+              <a:buNone/>
               <a:defRPr sz="2025" b="0">
                 <a:solidFill>
                   <a:srgbClr val="152A43"/>
@@ -6039,6 +5988,7 @@
               </a:defRPr>
             </a:lvl2pPr>
             <a:lvl3pPr>
+              <a:buNone/>
               <a:defRPr sz="2025" b="0">
                 <a:solidFill>
                   <a:srgbClr val="152A43"/>
@@ -6049,6 +5999,7 @@
               </a:defRPr>
             </a:lvl3pPr>
             <a:lvl4pPr>
+              <a:buNone/>
               <a:defRPr sz="2025" b="0">
                 <a:solidFill>
                   <a:srgbClr val="152A43"/>
@@ -6059,6 +6010,7 @@
               </a:defRPr>
             </a:lvl4pPr>
             <a:lvl5pPr>
+              <a:buNone/>
               <a:defRPr sz="2025" b="0">
                 <a:solidFill>
                   <a:srgbClr val="152A43"/>
@@ -6069,6 +6021,7 @@
               </a:defRPr>
             </a:lvl5pPr>
             <a:lvl6pPr>
+              <a:buNone/>
               <a:defRPr sz="2025" b="0">
                 <a:solidFill>
                   <a:srgbClr val="152A43"/>
@@ -6079,6 +6032,7 @@
               </a:defRPr>
             </a:lvl6pPr>
             <a:lvl7pPr>
+              <a:buNone/>
               <a:defRPr sz="2025" b="0">
                 <a:solidFill>
                   <a:srgbClr val="152A43"/>
@@ -6089,6 +6043,7 @@
               </a:defRPr>
             </a:lvl7pPr>
             <a:lvl8pPr>
+              <a:buNone/>
               <a:defRPr sz="2025" b="0">
                 <a:solidFill>
                   <a:srgbClr val="152A43"/>
@@ -6099,6 +6054,7 @@
               </a:defRPr>
             </a:lvl8pPr>
             <a:lvl9pPr>
+              <a:buNone/>
               <a:defRPr sz="2025" b="0">
                 <a:solidFill>
                   <a:srgbClr val="152A43"/>
@@ -6111,6 +6067,7 @@
           </a:lstStyle>
           <a:p xmlns:a="http://schemas.openxmlformats.org/drawingml/2006/main">
             <a:pPr>
+              <a:buNone/>
               <a:defRPr sz="2025" b="0">
                 <a:solidFill>
                   <a:srgbClr val="152A43"/>
@@ -6129,11 +6086,12 @@
                 <a:ea typeface="Arial"/>
                 <a:cs typeface="Arial"/>
               </a:rPr>
-              <a:t>Matched systems, oracle, budget and seeds</a:t>
+              <a:t>No benefit in this pair</a:t>
             </a:r>
           </a:p>
           <a:p xmlns:a="http://schemas.openxmlformats.org/drawingml/2006/main">
             <a:pPr>
+              <a:buNone/>
               <a:defRPr sz="2025" b="0">
                 <a:solidFill>
                   <a:srgbClr val="152A43"/>
@@ -6152,11 +6110,12 @@
                 <a:ea typeface="Arial"/>
                 <a:cs typeface="Arial"/>
               </a:rPr>
-              <a:t>Official mSUN@B, AUDC, AF/EF and cost</a:t>
+              <a:t>ON stayed in the Sn-Sr region</a:t>
             </a:r>
           </a:p>
           <a:p xmlns:a="http://schemas.openxmlformats.org/drawingml/2006/main">
             <a:pPr>
+              <a:buNone/>
               <a:defRPr sz="2025" b="0">
                 <a:solidFill>
                   <a:srgbClr val="152A43"/>
@@ -6175,7 +6134,7 @@
                 <a:ea typeface="Arial"/>
                 <a:cs typeface="Arial"/>
               </a:rPr>
-              <a:t>Two or three traceable discovery cases</a:t>
+              <a:t>Full-agent ablation after freeze</a:t>
             </a:r>
           </a:p>
         </p:txBody>
@@ -6221,6 +6180,7 @@
               </a:defRPr>
             </a:defPPr>
             <a:lvl1pPr>
+              <a:buNone/>
               <a:defRPr sz="1875" b="1">
                 <a:solidFill>
                   <a:srgbClr val="7C4614"/>
@@ -6231,6 +6191,7 @@
               </a:defRPr>
             </a:lvl1pPr>
             <a:lvl2pPr>
+              <a:buNone/>
               <a:defRPr sz="1875" b="1">
                 <a:solidFill>
                   <a:srgbClr val="7C4614"/>
@@ -6241,6 +6202,7 @@
               </a:defRPr>
             </a:lvl2pPr>
             <a:lvl3pPr>
+              <a:buNone/>
               <a:defRPr sz="1875" b="1">
                 <a:solidFill>
                   <a:srgbClr val="7C4614"/>
@@ -6251,6 +6213,7 @@
               </a:defRPr>
             </a:lvl3pPr>
             <a:lvl4pPr>
+              <a:buNone/>
               <a:defRPr sz="1875" b="1">
                 <a:solidFill>
                   <a:srgbClr val="7C4614"/>
@@ -6261,6 +6224,7 @@
               </a:defRPr>
             </a:lvl4pPr>
             <a:lvl5pPr>
+              <a:buNone/>
               <a:defRPr sz="1875" b="1">
                 <a:solidFill>
                   <a:srgbClr val="7C4614"/>
@@ -6271,6 +6235,7 @@
               </a:defRPr>
             </a:lvl5pPr>
             <a:lvl6pPr>
+              <a:buNone/>
               <a:defRPr sz="1875" b="1">
                 <a:solidFill>
                   <a:srgbClr val="7C4614"/>
@@ -6281,6 +6246,7 @@
               </a:defRPr>
             </a:lvl6pPr>
             <a:lvl7pPr>
+              <a:buNone/>
               <a:defRPr sz="1875" b="1">
                 <a:solidFill>
                   <a:srgbClr val="7C4614"/>
@@ -6291,6 +6257,7 @@
               </a:defRPr>
             </a:lvl7pPr>
             <a:lvl8pPr>
+              <a:buNone/>
               <a:defRPr sz="1875" b="1">
                 <a:solidFill>
                   <a:srgbClr val="7C4614"/>
@@ -6301,6 +6268,7 @@
               </a:defRPr>
             </a:lvl8pPr>
             <a:lvl9pPr>
+              <a:buNone/>
               <a:defRPr sz="1875" b="1">
                 <a:solidFill>
                   <a:srgbClr val="7C4614"/>
@@ -6313,6 +6281,7 @@
           </a:lstStyle>
           <a:p xmlns:a="http://schemas.openxmlformats.org/drawingml/2006/main">
             <a:pPr>
+              <a:buNone/>
               <a:defRPr sz="1875" b="1">
                 <a:solidFill>
                   <a:srgbClr val="7C4614"/>
@@ -6331,11 +6300,406 @@
                 <a:ea typeface="Arial"/>
                 <a:cs typeface="Arial"/>
               </a:rPr>
-              <a:t>Memory effect has not yet been measured.</a:t>
+              <a:t>Draft results. Final comparison pending.</a:t>
             </a:r>
           </a:p>
         </p:txBody>
       </p:sp>
+      <p:graphicFrame>
+        <p:nvGraphicFramePr>
+          <p:cNvPr id="11" name="">
+            <a:extLst xmlns:a="http://schemas.openxmlformats.org/drawingml/2006/main">
+              <a:ext uri="{FF2B5EF4-FFF2-40B4-BE49-F238E27FC236}">
+                <a16:creationId xmlns:a16="http://schemas.microsoft.com/office/drawing/2014/main" id="{15EC0710-1BA5-415D-914A-242574B3D030}"/>
+              </a:ext>
+            </a:extLst>
+          </p:cNvPr>
+          <p:cNvGraphicFramePr/>
+          <p:nvPr/>
+        </p:nvGraphicFramePr>
+        <p:xfrm>
+          <a:off xmlns:a="http://schemas.openxmlformats.org/drawingml/2006/main" x="6477000" y="2047875"/>
+          <a:ext xmlns:a="http://schemas.openxmlformats.org/drawingml/2006/main" cx="5105400" cy="1562100"/>
+        </p:xfrm>
+        <a:graphic xmlns:a="http://schemas.openxmlformats.org/drawingml/2006/main">
+          <a:graphicData uri="http://schemas.openxmlformats.org/drawingml/2006/table">
+            <a:tbl>
+              <a:tblPr/>
+              <a:tblGrid>
+                <a:gridCol w="2190750"/>
+                <a:gridCol w="1457325"/>
+                <a:gridCol w="1457325"/>
+              </a:tblGrid>
+              <a:tr h="520700">
+                <a:tc>
+                  <a:txBody>
+                    <a:bodyPr/>
+                    <a:lstStyle/>
+                    <a:p>
+                      <a:r>
+                        <a:rPr sz="1950" b="1">
+                          <a:solidFill>
+                            <a:srgbClr val="FFFFFF"/>
+                          </a:solidFill>
+                          <a:latin typeface="Arial"/>
+                          <a:ea typeface="Arial"/>
+                          <a:cs typeface="Arial"/>
+                        </a:rPr>
+                        <a:t>Metric</a:t>
+                      </a:r>
+                    </a:p>
+                  </a:txBody>
+                  <a:tcPr marL="91440" marR="91440" marT="45720" marB="45720">
+                    <a:lnL w="9525">
+                      <a:solidFill>
+                        <a:srgbClr val="D6DEE6"/>
+                      </a:solidFill>
+                      <a:prstDash val="solid"/>
+                    </a:lnL>
+                    <a:lnR w="9525">
+                      <a:solidFill>
+                        <a:srgbClr val="D6DEE6"/>
+                      </a:solidFill>
+                      <a:prstDash val="solid"/>
+                    </a:lnR>
+                    <a:lnT w="9525">
+                      <a:solidFill>
+                        <a:srgbClr val="D6DEE6"/>
+                      </a:solidFill>
+                      <a:prstDash val="solid"/>
+                    </a:lnT>
+                    <a:lnB w="9525">
+                      <a:solidFill>
+                        <a:srgbClr val="D6DEE6"/>
+                      </a:solidFill>
+                      <a:prstDash val="solid"/>
+                    </a:lnB>
+                    <a:solidFill>
+                      <a:srgbClr val="152A43"/>
+                    </a:solidFill>
+                  </a:tcPr>
+                </a:tc>
+                <a:tc>
+                  <a:txBody>
+                    <a:bodyPr/>
+                    <a:lstStyle/>
+                    <a:p>
+                      <a:r>
+                        <a:rPr sz="1950" b="1">
+                          <a:solidFill>
+                            <a:srgbClr val="FFFFFF"/>
+                          </a:solidFill>
+                          <a:latin typeface="Arial"/>
+                          <a:ea typeface="Arial"/>
+                          <a:cs typeface="Arial"/>
+                        </a:rPr>
+                        <a:t>ON</a:t>
+                      </a:r>
+                    </a:p>
+                  </a:txBody>
+                  <a:tcPr marL="91440" marR="91440" marT="45720" marB="45720">
+                    <a:lnR w="9525">
+                      <a:solidFill>
+                        <a:srgbClr val="D6DEE6"/>
+                      </a:solidFill>
+                      <a:prstDash val="solid"/>
+                    </a:lnR>
+                    <a:lnT w="9525">
+                      <a:solidFill>
+                        <a:srgbClr val="D6DEE6"/>
+                      </a:solidFill>
+                      <a:prstDash val="solid"/>
+                    </a:lnT>
+                    <a:lnB w="9525">
+                      <a:solidFill>
+                        <a:srgbClr val="D6DEE6"/>
+                      </a:solidFill>
+                      <a:prstDash val="solid"/>
+                    </a:lnB>
+                    <a:solidFill>
+                      <a:srgbClr val="152A43"/>
+                    </a:solidFill>
+                  </a:tcPr>
+                </a:tc>
+                <a:tc>
+                  <a:txBody>
+                    <a:bodyPr/>
+                    <a:lstStyle/>
+                    <a:p>
+                      <a:r>
+                        <a:rPr sz="1950" b="1">
+                          <a:solidFill>
+                            <a:srgbClr val="FFFFFF"/>
+                          </a:solidFill>
+                          <a:latin typeface="Arial"/>
+                          <a:ea typeface="Arial"/>
+                          <a:cs typeface="Arial"/>
+                        </a:rPr>
+                        <a:t>OFF</a:t>
+                      </a:r>
+                    </a:p>
+                  </a:txBody>
+                  <a:tcPr marL="91440" marR="91440" marT="45720" marB="45720">
+                    <a:lnR w="9525">
+                      <a:solidFill>
+                        <a:srgbClr val="D6DEE6"/>
+                      </a:solidFill>
+                      <a:prstDash val="solid"/>
+                    </a:lnR>
+                    <a:lnT w="9525">
+                      <a:solidFill>
+                        <a:srgbClr val="D6DEE6"/>
+                      </a:solidFill>
+                      <a:prstDash val="solid"/>
+                    </a:lnT>
+                    <a:lnB w="9525">
+                      <a:solidFill>
+                        <a:srgbClr val="D6DEE6"/>
+                      </a:solidFill>
+                      <a:prstDash val="solid"/>
+                    </a:lnB>
+                    <a:solidFill>
+                      <a:srgbClr val="152A43"/>
+                    </a:solidFill>
+                  </a:tcPr>
+                </a:tc>
+              </a:tr>
+              <a:tr h="520700">
+                <a:tc>
+                  <a:txBody>
+                    <a:bodyPr/>
+                    <a:lstStyle/>
+                    <a:p>
+                      <a:r>
+                        <a:rPr sz="1950" b="0">
+                          <a:solidFill>
+                            <a:srgbClr val="152A43"/>
+                          </a:solidFill>
+                          <a:latin typeface="Arial"/>
+                          <a:ea typeface="Arial"/>
+                          <a:cs typeface="Arial"/>
+                        </a:rPr>
+                        <a:t>mSUN@20</a:t>
+                      </a:r>
+                    </a:p>
+                  </a:txBody>
+                  <a:tcPr marL="91440" marR="91440" marT="45720" marB="45720">
+                    <a:lnL w="9525">
+                      <a:solidFill>
+                        <a:srgbClr val="D6DEE6"/>
+                      </a:solidFill>
+                      <a:prstDash val="solid"/>
+                    </a:lnL>
+                    <a:lnR w="9525">
+                      <a:solidFill>
+                        <a:srgbClr val="D6DEE6"/>
+                      </a:solidFill>
+                      <a:prstDash val="solid"/>
+                    </a:lnR>
+                    <a:lnB w="9525">
+                      <a:solidFill>
+                        <a:srgbClr val="D6DEE6"/>
+                      </a:solidFill>
+                      <a:prstDash val="solid"/>
+                    </a:lnB>
+                    <a:solidFill>
+                      <a:srgbClr val="FFFFFF"/>
+                    </a:solidFill>
+                  </a:tcPr>
+                </a:tc>
+                <a:tc>
+                  <a:txBody>
+                    <a:bodyPr/>
+                    <a:lstStyle/>
+                    <a:p>
+                      <a:r>
+                        <a:rPr sz="1950" b="0">
+                          <a:solidFill>
+                            <a:srgbClr val="152A43"/>
+                          </a:solidFill>
+                          <a:latin typeface="Arial"/>
+                          <a:ea typeface="Arial"/>
+                          <a:cs typeface="Arial"/>
+                        </a:rPr>
+                        <a:t>7</a:t>
+                      </a:r>
+                    </a:p>
+                  </a:txBody>
+                  <a:tcPr marL="91440" marR="91440" marT="45720" marB="45720">
+                    <a:lnR w="9525">
+                      <a:solidFill>
+                        <a:srgbClr val="D6DEE6"/>
+                      </a:solidFill>
+                      <a:prstDash val="solid"/>
+                    </a:lnR>
+                    <a:lnB w="9525">
+                      <a:solidFill>
+                        <a:srgbClr val="D6DEE6"/>
+                      </a:solidFill>
+                      <a:prstDash val="solid"/>
+                    </a:lnB>
+                    <a:solidFill>
+                      <a:srgbClr val="FFFFFF"/>
+                    </a:solidFill>
+                  </a:tcPr>
+                </a:tc>
+                <a:tc>
+                  <a:txBody>
+                    <a:bodyPr/>
+                    <a:lstStyle/>
+                    <a:p>
+                      <a:r>
+                        <a:rPr sz="1950" b="0">
+                          <a:solidFill>
+                            <a:srgbClr val="152A43"/>
+                          </a:solidFill>
+                          <a:latin typeface="Arial"/>
+                          <a:ea typeface="Arial"/>
+                          <a:cs typeface="Arial"/>
+                        </a:rPr>
+                        <a:t>8</a:t>
+                      </a:r>
+                    </a:p>
+                  </a:txBody>
+                  <a:tcPr marL="91440" marR="91440" marT="45720" marB="45720">
+                    <a:lnR w="9525">
+                      <a:solidFill>
+                        <a:srgbClr val="D6DEE6"/>
+                      </a:solidFill>
+                      <a:prstDash val="solid"/>
+                    </a:lnR>
+                    <a:lnB w="9525">
+                      <a:solidFill>
+                        <a:srgbClr val="D6DEE6"/>
+                      </a:solidFill>
+                      <a:prstDash val="solid"/>
+                    </a:lnB>
+                    <a:solidFill>
+                      <a:srgbClr val="FFFFFF"/>
+                    </a:solidFill>
+                  </a:tcPr>
+                </a:tc>
+              </a:tr>
+              <a:tr h="520700">
+                <a:tc>
+                  <a:txBody>
+                    <a:bodyPr/>
+                    <a:lstStyle/>
+                    <a:p>
+                      <a:r>
+                        <a:rPr sz="1950" b="0">
+                          <a:solidFill>
+                            <a:srgbClr val="152A43"/>
+                          </a:solidFill>
+                          <a:latin typeface="Arial"/>
+                          <a:ea typeface="Arial"/>
+                          <a:cs typeface="Arial"/>
+                        </a:rPr>
+                        <a:t>AUDC</a:t>
+                      </a:r>
+                    </a:p>
+                  </a:txBody>
+                  <a:tcPr marL="91440" marR="91440" marT="45720" marB="45720">
+                    <a:lnL w="9525">
+                      <a:solidFill>
+                        <a:srgbClr val="D6DEE6"/>
+                      </a:solidFill>
+                      <a:prstDash val="solid"/>
+                    </a:lnL>
+                    <a:lnR w="9525">
+                      <a:solidFill>
+                        <a:srgbClr val="D6DEE6"/>
+                      </a:solidFill>
+                      <a:prstDash val="solid"/>
+                    </a:lnR>
+                    <a:lnB w="9525">
+                      <a:solidFill>
+                        <a:srgbClr val="D6DEE6"/>
+                      </a:solidFill>
+                      <a:prstDash val="solid"/>
+                    </a:lnB>
+                    <a:solidFill>
+                      <a:srgbClr val="FFFFFF"/>
+                    </a:solidFill>
+                  </a:tcPr>
+                </a:tc>
+                <a:tc>
+                  <a:txBody>
+                    <a:bodyPr/>
+                    <a:lstStyle/>
+                    <a:p>
+                      <a:r>
+                        <a:rPr sz="1950" b="0">
+                          <a:solidFill>
+                            <a:srgbClr val="152A43"/>
+                          </a:solidFill>
+                          <a:latin typeface="Arial"/>
+                          <a:ea typeface="Arial"/>
+                          <a:cs typeface="Arial"/>
+                        </a:rPr>
+                        <a:t>68.5</a:t>
+                      </a:r>
+                    </a:p>
+                  </a:txBody>
+                  <a:tcPr marL="91440" marR="91440" marT="45720" marB="45720">
+                    <a:lnR w="9525">
+                      <a:solidFill>
+                        <a:srgbClr val="D6DEE6"/>
+                      </a:solidFill>
+                      <a:prstDash val="solid"/>
+                    </a:lnR>
+                    <a:lnB w="9525">
+                      <a:solidFill>
+                        <a:srgbClr val="D6DEE6"/>
+                      </a:solidFill>
+                      <a:prstDash val="solid"/>
+                    </a:lnB>
+                    <a:solidFill>
+                      <a:srgbClr val="FFFFFF"/>
+                    </a:solidFill>
+                  </a:tcPr>
+                </a:tc>
+                <a:tc>
+                  <a:txBody>
+                    <a:bodyPr/>
+                    <a:lstStyle/>
+                    <a:p>
+                      <a:r>
+                        <a:rPr sz="1950" b="0">
+                          <a:solidFill>
+                            <a:srgbClr val="152A43"/>
+                          </a:solidFill>
+                          <a:latin typeface="Arial"/>
+                          <a:ea typeface="Arial"/>
+                          <a:cs typeface="Arial"/>
+                        </a:rPr>
+                        <a:t>76.0</a:t>
+                      </a:r>
+                    </a:p>
+                  </a:txBody>
+                  <a:tcPr marL="91440" marR="91440" marT="45720" marB="45720">
+                    <a:lnR w="9525">
+                      <a:solidFill>
+                        <a:srgbClr val="D6DEE6"/>
+                      </a:solidFill>
+                      <a:prstDash val="solid"/>
+                    </a:lnR>
+                    <a:lnB w="9525">
+                      <a:solidFill>
+                        <a:srgbClr val="D6DEE6"/>
+                      </a:solidFill>
+                      <a:prstDash val="solid"/>
+                    </a:lnB>
+                    <a:solidFill>
+                      <a:srgbClr val="FFFFFF"/>
+                    </a:solidFill>
+                  </a:tcPr>
+                </a:tc>
+              </a:tr>
+            </a:tbl>
+          </a:graphicData>
+        </a:graphic>
+      </p:graphicFrame>
     </p:spTree>
     <p:extLst>
       <p:ext uri="{BB962C8B-B14F-4D97-AF65-F5344CB8AC3E}">

</xml_diff>